<commit_message>
Update 누구게 assets and add ZIP slides
Co-Authored-By: Claude Opus 4.6 (1M context) <noreply@anthropic.com>
</commit_message>
<xml_diff>
--- a/public/downloads/games/voice-guess/rules.pptx
+++ b/public/downloads/games/voice-guess/rules.pptx
@@ -14,16 +14,12 @@
   <p:notesSz cx="6858000" cy="9144000"/>
   <p:embeddedFontLst>
     <p:embeddedFont>
-      <p:font typeface="Jua" charset="1" panose="00000000000000000000"/>
+      <p:font typeface="무궁화 고딕" charset="1" panose="02020603020101020101"/>
       <p:regular r:id="rId10"/>
     </p:embeddedFont>
     <p:embeddedFont>
-      <p:font typeface="TDTD갬성명조" charset="1" panose="02000503000000000000"/>
+      <p:font typeface="무궁화 고딕 Bold" charset="1" panose="02020603020101020101"/>
       <p:regular r:id="rId11"/>
-    </p:embeddedFont>
-    <p:embeddedFont>
-      <p:font typeface="TDTD가온" charset="1" panose="02000503000000000000"/>
-      <p:regular r:id="rId12"/>
     </p:embeddedFont>
   </p:embeddedFontLst>
   <p:defaultTextStyle>
@@ -3141,8 +3137,8 @@
         </p:nvSpPr>
         <p:spPr>
           <a:xfrm rot="0">
-            <a:off x="1028700" y="3892867"/>
-            <a:ext cx="15555091" cy="2200275"/>
+            <a:off x="1028700" y="4178617"/>
+            <a:ext cx="15555091" cy="1914525"/>
           </a:xfrm>
           <a:prstGeom prst="rect">
             <a:avLst/>
@@ -3164,10 +3160,10 @@
                 <a:solidFill>
                   <a:srgbClr val="FFFAEF"/>
                 </a:solidFill>
-                <a:latin typeface="Jua"/>
-                <a:ea typeface="Jua"/>
-                <a:cs typeface="Jua"/>
-                <a:sym typeface="Jua"/>
+                <a:latin typeface="무궁화 고딕"/>
+                <a:ea typeface="무궁화 고딕"/>
+                <a:cs typeface="무궁화 고딕"/>
+                <a:sym typeface="무궁화 고딕"/>
               </a:rPr>
               <a:t>누구게?</a:t>
             </a:r>
@@ -3182,8 +3178,8 @@
         </p:nvSpPr>
         <p:spPr>
           <a:xfrm rot="0">
-            <a:off x="15264803" y="9812655"/>
-            <a:ext cx="2637975" cy="474345"/>
+            <a:off x="14522856" y="9822180"/>
+            <a:ext cx="3379923" cy="464820"/>
           </a:xfrm>
           <a:prstGeom prst="rect">
             <a:avLst/>
@@ -3208,10 +3204,10 @@
                 <a:solidFill>
                   <a:srgbClr val="FFFFFF"/>
                 </a:solidFill>
-                <a:latin typeface="TDTD갬성명조"/>
-                <a:ea typeface="TDTD갬성명조"/>
-                <a:cs typeface="TDTD갬성명조"/>
-                <a:sym typeface="TDTD갬성명조"/>
+                <a:latin typeface="무궁화 고딕"/>
+                <a:ea typeface="무궁화 고딕"/>
+                <a:cs typeface="무궁화 고딕"/>
+                <a:sym typeface="무궁화 고딕"/>
               </a:rPr>
               <a:t>ⓒ 2026. Sunday Play</a:t>
             </a:r>
@@ -3360,8 +3356,8 @@
         </p:nvSpPr>
         <p:spPr>
           <a:xfrm rot="0">
-            <a:off x="11392761" y="600705"/>
-            <a:ext cx="5362043" cy="1600200"/>
+            <a:off x="11392761" y="819780"/>
+            <a:ext cx="5362043" cy="1381125"/>
           </a:xfrm>
           <a:prstGeom prst="rect">
             <a:avLst/>
@@ -3383,10 +3379,10 @@
                 <a:solidFill>
                   <a:srgbClr val="FFFAEF"/>
                 </a:solidFill>
-                <a:latin typeface="Jua"/>
-                <a:ea typeface="Jua"/>
-                <a:cs typeface="Jua"/>
-                <a:sym typeface="Jua"/>
+                <a:latin typeface="무궁화 고딕"/>
+                <a:ea typeface="무궁화 고딕"/>
+                <a:cs typeface="무궁화 고딕"/>
+                <a:sym typeface="무궁화 고딕"/>
               </a:rPr>
               <a:t>규칙</a:t>
             </a:r>
@@ -3402,9 +3398,9 @@
         <p:grpSpPr>
           <a:xfrm rot="0">
             <a:off x="309172" y="535073"/>
-            <a:ext cx="10694683" cy="2573620"/>
+            <a:ext cx="10694683" cy="2406534"/>
             <a:chOff x="0" y="0"/>
-            <a:chExt cx="14259577" cy="3431493"/>
+            <a:chExt cx="14259577" cy="3208711"/>
           </a:xfrm>
         </p:grpSpPr>
         <p:sp>
@@ -3415,8 +3411,8 @@
           </p:nvSpPr>
           <p:spPr>
             <a:xfrm rot="0">
-              <a:off x="0" y="1380584"/>
-              <a:ext cx="14259577" cy="2050910"/>
+              <a:off x="0" y="1388378"/>
+              <a:ext cx="14259577" cy="1820333"/>
             </a:xfrm>
             <a:prstGeom prst="rect">
               <a:avLst/>
@@ -3430,18 +3426,18 @@
             <a:p>
               <a:pPr algn="l">
                 <a:lnSpc>
-                  <a:spcPts val="6273"/>
+                  <a:spcPts val="5599"/>
                 </a:lnSpc>
               </a:pPr>
               <a:r>
-                <a:rPr lang="en-US" sz="4480">
+                <a:rPr lang="en-US" sz="3999">
                   <a:solidFill>
                     <a:srgbClr val="FFFAEF"/>
                   </a:solidFill>
-                  <a:latin typeface="TDTD가온"/>
-                  <a:ea typeface="TDTD가온"/>
-                  <a:cs typeface="TDTD가온"/>
-                  <a:sym typeface="TDTD가온"/>
+                  <a:latin typeface="무궁화 고딕"/>
+                  <a:ea typeface="무궁화 고딕"/>
+                  <a:cs typeface="무궁화 고딕"/>
+                  <a:sym typeface="무궁화 고딕"/>
                 </a:rPr>
                 <a:t>도전자가 뒤돌아 섭니다.</a:t>
               </a:r>
@@ -3449,18 +3445,18 @@
             <a:p>
               <a:pPr algn="l">
                 <a:lnSpc>
-                  <a:spcPts val="6273"/>
+                  <a:spcPts val="5599"/>
                 </a:lnSpc>
               </a:pPr>
               <a:r>
-                <a:rPr lang="en-US" sz="4480">
+                <a:rPr lang="en-US" sz="3999">
                   <a:solidFill>
                     <a:srgbClr val="FFFAEF"/>
                   </a:solidFill>
-                  <a:latin typeface="TDTD가온"/>
-                  <a:ea typeface="TDTD가온"/>
-                  <a:cs typeface="TDTD가온"/>
-                  <a:sym typeface="TDTD가온"/>
+                  <a:latin typeface="무궁화 고딕"/>
+                  <a:ea typeface="무궁화 고딕"/>
+                  <a:cs typeface="무궁화 고딕"/>
+                  <a:sym typeface="무궁화 고딕"/>
                 </a:rPr>
                 <a:t>나머지는 순서를 정합니다.</a:t>
               </a:r>
@@ -3475,8 +3471,8 @@
           </p:nvSpPr>
           <p:spPr>
             <a:xfrm rot="0">
-              <a:off x="0" y="-171450"/>
-              <a:ext cx="9574913" cy="1169217"/>
+              <a:off x="0" y="-66675"/>
+              <a:ext cx="9574913" cy="1062712"/>
             </a:xfrm>
             <a:prstGeom prst="rect">
               <a:avLst/>
@@ -3498,10 +3494,10 @@
                   <a:solidFill>
                     <a:srgbClr val="FFFAEF"/>
                   </a:solidFill>
-                  <a:latin typeface="Jua"/>
-                  <a:ea typeface="Jua"/>
-                  <a:cs typeface="Jua"/>
-                  <a:sym typeface="Jua"/>
+                  <a:latin typeface="무궁화 고딕 Bold"/>
+                  <a:ea typeface="무궁화 고딕 Bold"/>
+                  <a:cs typeface="무궁화 고딕 Bold"/>
+                  <a:sym typeface="무궁화 고딕 Bold"/>
                 </a:rPr>
                 <a:t>STEP 1.</a:t>
               </a:r>
@@ -3518,9 +3514,9 @@
         <p:grpSpPr>
           <a:xfrm rot="0">
             <a:off x="9629694" y="7615163"/>
-            <a:ext cx="8487123" cy="3369474"/>
+            <a:ext cx="8487123" cy="3107563"/>
             <a:chOff x="0" y="0"/>
-            <a:chExt cx="11316164" cy="4492632"/>
+            <a:chExt cx="11316164" cy="4143417"/>
           </a:xfrm>
         </p:grpSpPr>
         <p:sp>
@@ -3531,8 +3527,8 @@
           </p:nvSpPr>
           <p:spPr>
             <a:xfrm rot="0">
-              <a:off x="0" y="1377534"/>
-              <a:ext cx="11143161" cy="3115098"/>
+              <a:off x="0" y="1383283"/>
+              <a:ext cx="11143161" cy="2760133"/>
             </a:xfrm>
             <a:prstGeom prst="rect">
               <a:avLst/>
@@ -3546,18 +3542,18 @@
             <a:p>
               <a:pPr algn="l">
                 <a:lnSpc>
-                  <a:spcPts val="6284"/>
+                  <a:spcPts val="5599"/>
                 </a:lnSpc>
               </a:pPr>
               <a:r>
-                <a:rPr lang="en-US" sz="4489">
+                <a:rPr lang="en-US" sz="3999">
                   <a:solidFill>
                     <a:srgbClr val="FFFAEF"/>
                   </a:solidFill>
-                  <a:latin typeface="TDTD가온"/>
-                  <a:ea typeface="TDTD가온"/>
-                  <a:cs typeface="TDTD가온"/>
-                  <a:sym typeface="TDTD가온"/>
+                  <a:latin typeface="무궁화 고딕"/>
+                  <a:ea typeface="무궁화 고딕"/>
+                  <a:cs typeface="무궁화 고딕"/>
+                  <a:sym typeface="무궁화 고딕"/>
                 </a:rPr>
                 <a:t>모두 끝나면 도전자가 뒤돌아 결과 확인.</a:t>
               </a:r>
@@ -3565,18 +3561,18 @@
             <a:p>
               <a:pPr algn="l">
                 <a:lnSpc>
-                  <a:spcPts val="6284"/>
+                  <a:spcPts val="5599"/>
                 </a:lnSpc>
               </a:pPr>
               <a:r>
-                <a:rPr lang="en-US" sz="4489">
+                <a:rPr lang="en-US" sz="3999">
                   <a:solidFill>
                     <a:srgbClr val="FFFAEF"/>
                   </a:solidFill>
-                  <a:latin typeface="TDTD가온"/>
-                  <a:ea typeface="TDTD가온"/>
-                  <a:cs typeface="TDTD가온"/>
-                  <a:sym typeface="TDTD가온"/>
+                  <a:latin typeface="무궁화 고딕"/>
+                  <a:ea typeface="무궁화 고딕"/>
+                  <a:cs typeface="무궁화 고딕"/>
+                  <a:sym typeface="무궁화 고딕"/>
                 </a:rPr>
                 <a:t>왼쪽에 있는 사람 수가 점수!</a:t>
               </a:r>
@@ -3584,7 +3580,7 @@
             <a:p>
               <a:pPr algn="l">
                 <a:lnSpc>
-                  <a:spcPts val="6284"/>
+                  <a:spcPts val="5599"/>
                 </a:lnSpc>
               </a:pPr>
             </a:p>
@@ -3598,8 +3594,8 @@
           </p:nvSpPr>
           <p:spPr>
             <a:xfrm rot="0">
-              <a:off x="0" y="-171450"/>
-              <a:ext cx="11316164" cy="1171105"/>
+              <a:off x="0" y="-57150"/>
+              <a:ext cx="11316164" cy="1053029"/>
             </a:xfrm>
             <a:prstGeom prst="rect">
               <a:avLst/>
@@ -3621,10 +3617,10 @@
                   <a:solidFill>
                     <a:srgbClr val="FFFAEF"/>
                   </a:solidFill>
-                  <a:latin typeface="Jua"/>
-                  <a:ea typeface="Jua"/>
-                  <a:cs typeface="Jua"/>
-                  <a:sym typeface="Jua"/>
+                  <a:latin typeface="무궁화 고딕 Bold"/>
+                  <a:ea typeface="무궁화 고딕 Bold"/>
+                  <a:cs typeface="무궁화 고딕 Bold"/>
+                  <a:sym typeface="무궁화 고딕 Bold"/>
                 </a:rPr>
                 <a:t>STEP 3.</a:t>
               </a:r>
@@ -3641,9 +3637,9 @@
         <p:grpSpPr>
           <a:xfrm rot="0">
             <a:off x="4528135" y="3604305"/>
-            <a:ext cx="10036683" cy="3364141"/>
+            <a:ext cx="10417683" cy="3107111"/>
             <a:chOff x="0" y="0"/>
-            <a:chExt cx="13382244" cy="4485521"/>
+            <a:chExt cx="13890244" cy="4142815"/>
           </a:xfrm>
         </p:grpSpPr>
         <p:sp>
@@ -3654,8 +3650,8 @@
           </p:nvSpPr>
           <p:spPr>
             <a:xfrm rot="0">
-              <a:off x="0" y="1375218"/>
-              <a:ext cx="13382244" cy="3110303"/>
+              <a:off x="0" y="1382681"/>
+              <a:ext cx="13890244" cy="2760133"/>
             </a:xfrm>
             <a:prstGeom prst="rect">
               <a:avLst/>
@@ -3669,18 +3665,18 @@
             <a:p>
               <a:pPr algn="l">
                 <a:lnSpc>
-                  <a:spcPts val="6275"/>
+                  <a:spcPts val="5599"/>
                 </a:lnSpc>
               </a:pPr>
               <a:r>
-                <a:rPr lang="en-US" sz="4482">
+                <a:rPr lang="en-US" sz="3999">
                   <a:solidFill>
                     <a:srgbClr val="FFFAEF"/>
                   </a:solidFill>
-                  <a:latin typeface="TDTD가온"/>
-                  <a:ea typeface="TDTD가온"/>
-                  <a:cs typeface="TDTD가온"/>
-                  <a:sym typeface="TDTD가온"/>
+                  <a:latin typeface="무궁화 고딕"/>
+                  <a:ea typeface="무궁화 고딕"/>
+                  <a:cs typeface="무궁화 고딕"/>
+                  <a:sym typeface="무궁화 고딕"/>
                 </a:rPr>
                 <a:t>한 명씩 같은 단어(ex. "안녕하세요")를 말합니다.</a:t>
               </a:r>
@@ -3688,18 +3684,18 @@
             <a:p>
               <a:pPr algn="l">
                 <a:lnSpc>
-                  <a:spcPts val="6275"/>
+                  <a:spcPts val="5599"/>
                 </a:lnSpc>
               </a:pPr>
               <a:r>
-                <a:rPr lang="en-US" sz="4482">
+                <a:rPr lang="en-US" sz="3999">
                   <a:solidFill>
                     <a:srgbClr val="FFFAEF"/>
                   </a:solidFill>
-                  <a:latin typeface="TDTD가온"/>
-                  <a:ea typeface="TDTD가온"/>
-                  <a:cs typeface="TDTD가온"/>
-                  <a:sym typeface="TDTD가온"/>
+                  <a:latin typeface="무궁화 고딕"/>
+                  <a:ea typeface="무궁화 고딕"/>
+                  <a:cs typeface="무궁화 고딕"/>
+                  <a:sym typeface="무궁화 고딕"/>
                 </a:rPr>
                 <a:t>도전자는 누구인지 즉시 답하고,</a:t>
               </a:r>
@@ -3707,18 +3703,18 @@
             <a:p>
               <a:pPr algn="l">
                 <a:lnSpc>
-                  <a:spcPts val="6275"/>
+                  <a:spcPts val="5599"/>
                 </a:lnSpc>
               </a:pPr>
               <a:r>
-                <a:rPr lang="en-US" sz="4482">
+                <a:rPr lang="en-US" sz="3999">
                   <a:solidFill>
                     <a:srgbClr val="FFFAEF"/>
                   </a:solidFill>
-                  <a:latin typeface="TDTD가온"/>
-                  <a:ea typeface="TDTD가온"/>
-                  <a:cs typeface="TDTD가온"/>
-                  <a:sym typeface="TDTD가온"/>
+                  <a:latin typeface="무궁화 고딕"/>
+                  <a:ea typeface="무궁화 고딕"/>
+                  <a:cs typeface="무궁화 고딕"/>
+                  <a:sym typeface="무궁화 고딕"/>
                 </a:rPr>
                 <a:t>맞으면 왼쪽 / 틀리면 오른쪽으로 이동!</a:t>
               </a:r>
@@ -3733,8 +3729,8 @@
           </p:nvSpPr>
           <p:spPr>
             <a:xfrm rot="0">
-              <a:off x="0" y="-171450"/>
-              <a:ext cx="8250286" cy="1169523"/>
+              <a:off x="0" y="-57150"/>
+              <a:ext cx="8563473" cy="1053161"/>
             </a:xfrm>
             <a:prstGeom prst="rect">
               <a:avLst/>
@@ -3756,10 +3752,10 @@
                   <a:solidFill>
                     <a:srgbClr val="FFFAEF"/>
                   </a:solidFill>
-                  <a:latin typeface="Jua"/>
-                  <a:ea typeface="Jua"/>
-                  <a:cs typeface="Jua"/>
-                  <a:sym typeface="Jua"/>
+                  <a:latin typeface="무궁화 고딕 Bold"/>
+                  <a:ea typeface="무궁화 고딕 Bold"/>
+                  <a:cs typeface="무궁화 고딕 Bold"/>
+                  <a:sym typeface="무궁화 고딕 Bold"/>
                 </a:rPr>
                 <a:t>STEP 2.</a:t>
               </a:r>
@@ -3857,8 +3853,8 @@
         </p:nvSpPr>
         <p:spPr>
           <a:xfrm rot="0">
-            <a:off x="1028700" y="3892867"/>
-            <a:ext cx="15555091" cy="2200275"/>
+            <a:off x="1028700" y="4178617"/>
+            <a:ext cx="15555091" cy="1914525"/>
           </a:xfrm>
           <a:prstGeom prst="rect">
             <a:avLst/>
@@ -3880,10 +3876,10 @@
                 <a:solidFill>
                   <a:srgbClr val="FFFAEF"/>
                 </a:solidFill>
-                <a:latin typeface="Jua"/>
-                <a:ea typeface="Jua"/>
-                <a:cs typeface="Jua"/>
-                <a:sym typeface="Jua"/>
+                <a:latin typeface="무궁화 고딕"/>
+                <a:ea typeface="무궁화 고딕"/>
+                <a:cs typeface="무궁화 고딕"/>
+                <a:sym typeface="무궁화 고딕"/>
               </a:rPr>
               <a:t>누구게?</a:t>
             </a:r>
@@ -3898,8 +3894,8 @@
         </p:nvSpPr>
         <p:spPr>
           <a:xfrm rot="0">
-            <a:off x="15264803" y="9812655"/>
-            <a:ext cx="2637975" cy="474345"/>
+            <a:off x="14522856" y="9822180"/>
+            <a:ext cx="3379923" cy="464820"/>
           </a:xfrm>
           <a:prstGeom prst="rect">
             <a:avLst/>
@@ -3924,10 +3920,10 @@
                 <a:solidFill>
                   <a:srgbClr val="FFFFFF"/>
                 </a:solidFill>
-                <a:latin typeface="TDTD갬성명조"/>
-                <a:ea typeface="TDTD갬성명조"/>
-                <a:cs typeface="TDTD갬성명조"/>
-                <a:sym typeface="TDTD갬성명조"/>
+                <a:latin typeface="무궁화 고딕"/>
+                <a:ea typeface="무궁화 고딕"/>
+                <a:cs typeface="무궁화 고딕"/>
+                <a:sym typeface="무궁화 고딕"/>
               </a:rPr>
               <a:t>ⓒ 2026. Sunday Play</a:t>
             </a:r>
@@ -3999,8 +3995,8 @@
         </p:nvSpPr>
         <p:spPr>
           <a:xfrm rot="0">
-            <a:off x="4421807" y="3895725"/>
-            <a:ext cx="9444385" cy="2200275"/>
+            <a:off x="4421807" y="4181475"/>
+            <a:ext cx="9444385" cy="1914525"/>
           </a:xfrm>
           <a:prstGeom prst="rect">
             <a:avLst/>
@@ -4022,10 +4018,10 @@
                 <a:solidFill>
                   <a:srgbClr val="000000"/>
                 </a:solidFill>
-                <a:latin typeface="Jua"/>
-                <a:ea typeface="Jua"/>
-                <a:cs typeface="Jua"/>
-                <a:sym typeface="Jua"/>
+                <a:latin typeface="무궁화 고딕"/>
+                <a:ea typeface="무궁화 고딕"/>
+                <a:cs typeface="무궁화 고딕"/>
+                <a:sym typeface="무궁화 고딕"/>
               </a:rPr>
               <a:t>감사합니다!</a:t>
             </a:r>

</xml_diff>